<commit_message>
Power Point Jakob Änderungen
</commit_message>
<xml_diff>
--- a/docs/Olist-Ecommerce.pptx
+++ b/docs/Olist-Ecommerce.pptx
@@ -14486,40 +14486,67 @@
             <p:ph type="ctrTitle"/>
           </p:nvPr>
         </p:nvSpPr>
-        <p:spPr/>
+        <p:spPr>
+          <a:xfrm>
+            <a:off x="192024" y="5230368"/>
+            <a:ext cx="11193731" cy="1480979"/>
+          </a:xfrm>
+        </p:spPr>
         <p:txBody>
-          <a:bodyPr/>
+          <a:bodyPr>
+            <a:normAutofit fontScale="90000"/>
+          </a:bodyPr>
           <a:lstStyle/>
           <a:p>
-            <a:endParaRPr lang="de-DE"/>
+            <a:br>
+              <a:rPr lang="de-DE" sz="3100" b="1" dirty="0"/>
+            </a:br>
+            <a:br>
+              <a:rPr lang="de-DE" sz="3100" b="1" dirty="0"/>
+            </a:br>
+            <a:br>
+              <a:rPr lang="de-DE" sz="4000" dirty="0"/>
+            </a:br>
+            <a:endParaRPr lang="de-DE" sz="4000" b="1" dirty="0"/>
           </a:p>
         </p:txBody>
       </p:sp>
-      <p:sp>
-        <p:nvSpPr>
-          <p:cNvPr id="3" name="Untertitel 2">
+      <p:pic>
+        <p:nvPicPr>
+          <p:cNvPr id="5" name="Grafik 4">
             <a:extLst>
               <a:ext uri="{FF2B5EF4-FFF2-40B4-BE49-F238E27FC236}">
-                <a16:creationId xmlns:a16="http://schemas.microsoft.com/office/drawing/2014/main" id="{0A8EBB58-D4FF-F307-D7E7-4DEE04BE23ED}"/>
+                <a16:creationId xmlns:a16="http://schemas.microsoft.com/office/drawing/2014/main" id="{88FB54E8-350C-1BED-27DB-2E0E95E06E64}"/>
               </a:ext>
             </a:extLst>
           </p:cNvPr>
-          <p:cNvSpPr>
-            <a:spLocks noGrp="1"/>
-          </p:cNvSpPr>
-          <p:nvPr>
-            <p:ph type="subTitle" idx="1"/>
-          </p:nvPr>
-        </p:nvSpPr>
-        <p:spPr/>
-        <p:txBody>
-          <a:bodyPr/>
-          <a:lstStyle/>
-          <a:p>
-            <a:endParaRPr lang="de-DE"/>
-          </a:p>
-        </p:txBody>
-      </p:sp>
+          <p:cNvPicPr>
+            <a:picLocks noChangeAspect="1"/>
+          </p:cNvPicPr>
+          <p:nvPr/>
+        </p:nvPicPr>
+        <p:blipFill>
+          <a:blip r:embed="rId2">
+            <a:extLst>
+              <a:ext uri="{28A0092B-C50C-407E-A947-70E740481C1C}">
+                <a14:useLocalDpi xmlns:a14="http://schemas.microsoft.com/office/drawing/2010/main" val="0"/>
+              </a:ext>
+            </a:extLst>
+          </a:blip>
+          <a:stretch>
+            <a:fillRect/>
+          </a:stretch>
+        </p:blipFill>
+        <p:spPr>
+          <a:xfrm>
+            <a:off x="1577340" y="267536"/>
+            <a:ext cx="9037320" cy="4822335"/>
+          </a:xfrm>
+          <a:prstGeom prst="rect">
+            <a:avLst/>
+          </a:prstGeom>
+        </p:spPr>
+      </p:pic>
     </p:spTree>
     <p:extLst>
       <p:ext uri="{BB962C8B-B14F-4D97-AF65-F5344CB8AC3E}">
@@ -14893,6 +14920,18 @@
               <a:t>Power BI Workspace</a:t>
             </a:r>
           </a:p>
+          <a:p>
+            <a:r>
+              <a:rPr lang="de-DE" dirty="0"/>
+              <a:t>Mehrfachkäufe pro Kunde zu finden</a:t>
+            </a:r>
+          </a:p>
+          <a:p>
+            <a:r>
+              <a:rPr lang="de-DE" dirty="0"/>
+              <a:t>Komplette Postleitzahlen um alle Bereiche abdecken zu können</a:t>
+            </a:r>
+          </a:p>
         </p:txBody>
       </p:sp>
     </p:spTree>
@@ -14971,7 +15010,9 @@
         </p:nvSpPr>
         <p:spPr/>
         <p:txBody>
-          <a:bodyPr/>
+          <a:bodyPr>
+            <a:normAutofit lnSpcReduction="10000"/>
+          </a:bodyPr>
           <a:lstStyle/>
           <a:p>
             <a:r>
@@ -14995,6 +15036,66 @@
             <a:r>
               <a:rPr lang="de-DE" dirty="0"/>
               <a:t>Arbeit im Team und GitHub</a:t>
+            </a:r>
+          </a:p>
+          <a:p>
+            <a:r>
+              <a:rPr lang="de-DE" dirty="0"/>
+              <a:t>Pipelines mit </a:t>
+            </a:r>
+            <a:r>
+              <a:rPr lang="de-DE" dirty="0" err="1"/>
+              <a:t>API‘s</a:t>
+            </a:r>
+            <a:r>
+              <a:rPr lang="de-DE" dirty="0"/>
+              <a:t> zu bauen</a:t>
+            </a:r>
+          </a:p>
+          <a:p>
+            <a:r>
+              <a:rPr lang="de-DE" dirty="0" err="1"/>
+              <a:t>Scrum</a:t>
+            </a:r>
+            <a:r>
+              <a:rPr lang="de-DE" dirty="0"/>
+              <a:t> anwenden</a:t>
+            </a:r>
+          </a:p>
+          <a:p>
+            <a:r>
+              <a:rPr lang="de-DE" dirty="0"/>
+              <a:t>Mapping, </a:t>
+            </a:r>
+            <a:r>
+              <a:rPr lang="de-DE" dirty="0" err="1"/>
+              <a:t>join</a:t>
+            </a:r>
+            <a:r>
+              <a:rPr lang="de-DE" dirty="0"/>
+              <a:t> im </a:t>
+            </a:r>
+            <a:r>
+              <a:rPr lang="de-DE" dirty="0" err="1"/>
+              <a:t>Preprocessing</a:t>
+            </a:r>
+            <a:r>
+              <a:rPr lang="de-DE" dirty="0"/>
+              <a:t> zum </a:t>
+            </a:r>
+            <a:r>
+              <a:rPr lang="de-DE" dirty="0" err="1"/>
+              <a:t>Anomalieausschluss</a:t>
+            </a:r>
+            <a:r>
+              <a:rPr lang="de-DE" dirty="0"/>
+              <a:t> zu verwenden</a:t>
+            </a:r>
+          </a:p>
+          <a:p>
+            <a:r>
+              <a:rPr lang="de-DE" dirty="0"/>
+              <a:t>Galaxy Schema mit 2 Faktentabellen bauen</a:t>
             </a:r>
           </a:p>
         </p:txBody>
@@ -15086,7 +15187,10 @@
           <a:bodyPr/>
           <a:lstStyle/>
           <a:p>
-            <a:endParaRPr lang="de-DE"/>
+            <a:r>
+              <a:rPr lang="de-DE" dirty="0"/>
+              <a:t>Verpackungskosten und Lieferzeit können optimiert werden. Kostenlose Lieferungen könnten eine Möglichkeit sein.</a:t>
+            </a:r>
           </a:p>
         </p:txBody>
       </p:sp>

</xml_diff>